<commit_message>
Notebook execution complete + final slides + recording script
Results:
- HistGradBoost wins (val AUC 0.7595)
- Logistic Regression 0.7487, Random Forest 0.7470
- Deep MLP 0.7416, Shallow MLP 0.7405
- Imbalance study: at threshold 0.5, MLP has 0 recall
- SMOTE hurt MLP AUC (0.745 -> 0.648)
- Threshold tuning at 0.164: precision 0.24, recall 0.40, F1 0.30
- Insight: choosing the threshold matters more than resampling

Artifacts: 5 CV CSVs, imbalance_compare.csv, combined_model_comparison.csv,
submission CSV, 3 chart PNGs, 10-slide deck, recording script.
</commit_message>
<xml_diff>
--- a/slides/final_presentation.pptx
+++ b/slides/final_presentation.pptx
@@ -3597,8 +3597,8 @@
         </p:nvSpPr>
         <p:spPr>
           <a:xfrm>
-            <a:off x="548640" y="1005840"/>
-            <a:ext cx="11091672" cy="5303520"/>
+            <a:off x="457200" y="1005840"/>
+            <a:ext cx="6035040" cy="5303520"/>
           </a:xfrm>
           <a:prstGeom prst="rect">
             <a:avLst/>
@@ -3624,15 +3624,15 @@
           <a:p>
             <a:pPr/>
             <a:r>
-              <a:rPr sz="1600" b="0"/>
-              <a:t>• Train: 307,511 applicants × 122 features (102 numeric, 16 categorical, IDs, target)</a:t>
+              <a:rPr sz="1400" b="0"/>
+              <a:t>• Train: 307,511 applicants × 122 features</a:t>
             </a:r>
           </a:p>
           <a:p>
             <a:pPr/>
             <a:r>
-              <a:rPr sz="1600" b="0"/>
-              <a:t>• Test:   48,744 applicants (Kaggle hidden labels)</a:t>
+              <a:rPr sz="1400" b="0"/>
+              <a:t>• Test: 48,744 applicants (labels held out by Kaggle)</a:t>
             </a:r>
           </a:p>
           <a:p>
@@ -3646,21 +3646,21 @@
                   <a:srgbClr val="1F3A68"/>
                 </a:solidFill>
               </a:rPr>
-              <a:t>Class balance</a:t>
+              <a:t>Severe class imbalance</a:t>
             </a:r>
           </a:p>
           <a:p>
             <a:pPr/>
             <a:r>
-              <a:rPr sz="1600" b="0"/>
-              <a:t>• TARGET = 1  (default):    24,825   ≈ 8.07%</a:t>
+              <a:rPr sz="1400" b="0"/>
+              <a:t>• Default rate ≈ 8.07% (24,825 / 307,511).</a:t>
             </a:r>
           </a:p>
           <a:p>
             <a:pPr/>
             <a:r>
-              <a:rPr sz="1600" b="0"/>
-              <a:t>• TARGET = 0  (no default): 282,686   ≈ 91.93%</a:t>
+              <a:rPr sz="1400" b="0"/>
+              <a:t>• Naive "all-zero" model = 92% accuracy / 0 recall.</a:t>
             </a:r>
           </a:p>
           <a:p>
@@ -3674,32 +3674,56 @@
                   <a:srgbClr val="1F3A68"/>
                 </a:solidFill>
               </a:rPr>
-              <a:t>Key feature observations</a:t>
+              <a:t>Key feature signals</a:t>
             </a:r>
           </a:p>
           <a:p>
             <a:pPr/>
             <a:r>
-              <a:rPr sz="1600" b="0"/>
+              <a:rPr sz="1400" b="0"/>
               <a:t>• EXT_SOURCE_1/2/3 (external credit scores) are the strongest predictors (|ρ| ≈ 0.16–0.18).</a:t>
             </a:r>
           </a:p>
           <a:p>
             <a:pPr/>
             <a:r>
-              <a:rPr sz="1600" b="0"/>
-              <a:t>• DAYS_EMPLOYED has a sentinel value 365 243 in 18% of rows (not employed).</a:t>
+              <a:rPr sz="1400" b="0"/>
+              <a:t>• DAYS_EMPLOYED sentinel 365,243 flags 18% (unemployed).</a:t>
             </a:r>
           </a:p>
           <a:p>
             <a:pPr/>
             <a:r>
-              <a:rPr sz="1600" b="0"/>
-              <a:t>• Building-info columns are 50–70% missing — handled via mean imputation.</a:t>
-            </a:r>
-          </a:p>
-        </p:txBody>
-      </p:sp>
+              <a:rPr sz="1400" b="0"/>
+              <a:t>• Building-info columns are 50–70% missing.</a:t>
+            </a:r>
+          </a:p>
+        </p:txBody>
+      </p:sp>
+      <p:pic>
+        <p:nvPicPr>
+          <p:cNvPr id="4" name="Picture 3" descr="class_balance.png"/>
+          <p:cNvPicPr>
+            <a:picLocks noChangeAspect="1"/>
+          </p:cNvPicPr>
+          <p:nvPr/>
+        </p:nvPicPr>
+        <p:blipFill>
+          <a:blip r:embed="rId2"/>
+          <a:stretch>
+            <a:fillRect/>
+          </a:stretch>
+        </p:blipFill>
+        <p:spPr>
+          <a:xfrm>
+            <a:off x="6675120" y="1828800"/>
+            <a:ext cx="5212080" cy="2782426"/>
+          </a:xfrm>
+          <a:prstGeom prst="rect">
+            <a:avLst/>
+          </a:prstGeom>
+        </p:spPr>
+      </p:pic>
     </p:spTree>
   </p:cSld>
   <p:clrMapOvr>
@@ -4533,17 +4557,41 @@
           </a:p>
         </p:txBody>
       </p:sp>
+      <p:pic>
+        <p:nvPicPr>
+          <p:cNvPr id="3" name="Picture 2" descr="model_auc_bar.png"/>
+          <p:cNvPicPr>
+            <a:picLocks noChangeAspect="1"/>
+          </p:cNvPicPr>
+          <p:nvPr/>
+        </p:nvPicPr>
+        <p:blipFill>
+          <a:blip r:embed="rId2"/>
+          <a:stretch>
+            <a:fillRect/>
+          </a:stretch>
+        </p:blipFill>
+        <p:spPr>
+          <a:xfrm>
+            <a:off x="365760" y="1097280"/>
+            <a:ext cx="6949440" cy="3642893"/>
+          </a:xfrm>
+          <a:prstGeom prst="rect">
+            <a:avLst/>
+          </a:prstGeom>
+        </p:spPr>
+      </p:pic>
       <p:graphicFrame>
         <p:nvGraphicFramePr>
-          <p:cNvPr id="3" name="Table 2"/>
+          <p:cNvPr id="4" name="Table 3"/>
           <p:cNvGraphicFramePr>
             <a:graphicFrameLocks noGrp="1"/>
           </p:cNvGraphicFramePr>
           <p:nvPr/>
         </p:nvGraphicFramePr>
         <p:xfrm>
-          <a:off x="548640" y="1188720"/>
-          <a:ext cx="11064240" cy="3200400"/>
+          <a:off x="7589520" y="1280160"/>
+          <a:ext cx="4297680" cy="2743200"/>
         </p:xfrm>
         <a:graphic>
           <a:graphicData uri="http://schemas.openxmlformats.org/drawingml/2006/table">
@@ -4552,11 +4600,10 @@
                 <a:tableStyleId>{5C22544A-7EE6-4342-B048-85BDC9FD1C3A}</a:tableStyleId>
               </a:tblPr>
               <a:tblGrid>
-                <a:gridCol w="3931920"/>
-                <a:gridCol w="1463040"/>
-                <a:gridCol w="5669280"/>
+                <a:gridCol w="2743200"/>
+                <a:gridCol w="1554480"/>
               </a:tblGrid>
-              <a:tr h="533400">
+              <a:tr h="457200">
                 <a:tc>
                   <a:txBody>
                     <a:bodyPr/>
@@ -4568,7 +4615,7 @@
                             <a:srgbClr val="FFFFFF"/>
                           </a:solidFill>
                         </a:rPr>
-                        <a:t>model</a:t>
+                        <a:t>Model</a:t>
                       </a:r>
                     </a:p>
                   </a:txBody>
@@ -4589,7 +4636,7 @@
                             <a:srgbClr val="FFFFFF"/>
                           </a:solidFill>
                         </a:rPr>
-                        <a:t>best_val_AUC</a:t>
+                        <a:t>AUC</a:t>
                       </a:r>
                     </a:p>
                   </a:txBody>
@@ -4599,29 +4646,8 @@
                     </a:solidFill>
                   </a:tcPr>
                 </a:tc>
-                <a:tc>
-                  <a:txBody>
-                    <a:bodyPr/>
-                    <a:lstStyle/>
-                    <a:p>
-                      <a:r>
-                        <a:rPr b="1" sz="1300">
-                          <a:solidFill>
-                            <a:srgbClr val="FFFFFF"/>
-                          </a:solidFill>
-                        </a:rPr>
-                        <a:t>best_params</a:t>
-                      </a:r>
-                    </a:p>
-                  </a:txBody>
-                  <a:tcPr>
-                    <a:solidFill>
-                      <a:srgbClr val="2E86C1"/>
-                    </a:solidFill>
-                  </a:tcPr>
-                </a:tc>
               </a:tr>
-              <a:tr h="533400">
+              <a:tr h="457200">
                 <a:tc>
                   <a:txBody>
                     <a:bodyPr/>
@@ -4629,7 +4655,119 @@
                     <a:p>
                       <a:r>
                         <a:rPr sz="1100"/>
-                        <a:t>Shallow MLP (Minwoo)</a:t>
+                        <a:t>HistGradBoost</a:t>
+                      </a:r>
+                    </a:p>
+                  </a:txBody>
+                  <a:tcPr/>
+                </a:tc>
+                <a:tc>
+                  <a:txBody>
+                    <a:bodyPr/>
+                    <a:lstStyle/>
+                    <a:p>
+                      <a:r>
+                        <a:rPr sz="1100"/>
+                        <a:t>0.7595</a:t>
+                      </a:r>
+                    </a:p>
+                  </a:txBody>
+                  <a:tcPr/>
+                </a:tc>
+              </a:tr>
+              <a:tr h="457200">
+                <a:tc>
+                  <a:txBody>
+                    <a:bodyPr/>
+                    <a:lstStyle/>
+                    <a:p>
+                      <a:r>
+                        <a:rPr sz="1100"/>
+                        <a:t>Logistic Regression</a:t>
+                      </a:r>
+                    </a:p>
+                  </a:txBody>
+                  <a:tcPr/>
+                </a:tc>
+                <a:tc>
+                  <a:txBody>
+                    <a:bodyPr/>
+                    <a:lstStyle/>
+                    <a:p>
+                      <a:r>
+                        <a:rPr sz="1100"/>
+                        <a:t>0.7487</a:t>
+                      </a:r>
+                    </a:p>
+                  </a:txBody>
+                  <a:tcPr/>
+                </a:tc>
+              </a:tr>
+              <a:tr h="457200">
+                <a:tc>
+                  <a:txBody>
+                    <a:bodyPr/>
+                    <a:lstStyle/>
+                    <a:p>
+                      <a:r>
+                        <a:rPr sz="1100"/>
+                        <a:t>Random Forest</a:t>
+                      </a:r>
+                    </a:p>
+                  </a:txBody>
+                  <a:tcPr/>
+                </a:tc>
+                <a:tc>
+                  <a:txBody>
+                    <a:bodyPr/>
+                    <a:lstStyle/>
+                    <a:p>
+                      <a:r>
+                        <a:rPr sz="1100"/>
+                        <a:t>0.7470</a:t>
+                      </a:r>
+                    </a:p>
+                  </a:txBody>
+                  <a:tcPr/>
+                </a:tc>
+              </a:tr>
+              <a:tr h="457200">
+                <a:tc>
+                  <a:txBody>
+                    <a:bodyPr/>
+                    <a:lstStyle/>
+                    <a:p>
+                      <a:r>
+                        <a:rPr sz="1100"/>
+                        <a:t>Deep MLP</a:t>
+                      </a:r>
+                    </a:p>
+                  </a:txBody>
+                  <a:tcPr/>
+                </a:tc>
+                <a:tc>
+                  <a:txBody>
+                    <a:bodyPr/>
+                    <a:lstStyle/>
+                    <a:p>
+                      <a:r>
+                        <a:rPr sz="1100"/>
+                        <a:t>0.7416</a:t>
+                      </a:r>
+                    </a:p>
+                  </a:txBody>
+                  <a:tcPr/>
+                </a:tc>
+              </a:tr>
+              <a:tr h="457200">
+                <a:tc>
+                  <a:txBody>
+                    <a:bodyPr/>
+                    <a:lstStyle/>
+                    <a:p>
+                      <a:r>
+                        <a:rPr sz="1100"/>
+                        <a:t>Shallow MLP</a:t>
                       </a:r>
                     </a:p>
                   </a:txBody>
@@ -4643,183 +4781,6 @@
                       <a:r>
                         <a:rPr sz="1100"/>
                         <a:t>0.7405</a:t>
-                      </a:r>
-                    </a:p>
-                  </a:txBody>
-                  <a:tcPr/>
-                </a:tc>
-                <a:tc>
-                  <a:txBody>
-                    <a:bodyPr/>
-                    <a:lstStyle/>
-                    <a:p>
-                      <a:r>
-                        <a:rPr sz="1100"/>
-                        <a:t>{'model__alpha': 0.001, 'model__learning_rate_init': 0.005}</a:t>
-                      </a:r>
-                    </a:p>
-                  </a:txBody>
-                  <a:tcPr/>
-                </a:tc>
-              </a:tr>
-              <a:tr h="533400">
-                <a:tc>
-                  <a:txBody>
-                    <a:bodyPr/>
-                    <a:lstStyle/>
-                    <a:p>
-                      <a:r>
-                        <a:rPr sz="1100"/>
-                        <a:t>Logistic Regression (Nathan)</a:t>
-                      </a:r>
-                    </a:p>
-                  </a:txBody>
-                  <a:tcPr/>
-                </a:tc>
-                <a:tc>
-                  <a:txBody>
-                    <a:bodyPr/>
-                    <a:lstStyle/>
-                    <a:p>
-                      <a:r>
-                        <a:rPr sz="1100"/>
-                        <a:t>TBD</a:t>
-                      </a:r>
-                    </a:p>
-                  </a:txBody>
-                  <a:tcPr/>
-                </a:tc>
-                <a:tc>
-                  <a:txBody>
-                    <a:bodyPr/>
-                    <a:lstStyle/>
-                    <a:p>
-                      <a:r>
-                        <a:rPr sz="1100"/>
-                        <a:t>TBD</a:t>
-                      </a:r>
-                    </a:p>
-                  </a:txBody>
-                  <a:tcPr/>
-                </a:tc>
-              </a:tr>
-              <a:tr h="533400">
-                <a:tc>
-                  <a:txBody>
-                    <a:bodyPr/>
-                    <a:lstStyle/>
-                    <a:p>
-                      <a:r>
-                        <a:rPr sz="1100"/>
-                        <a:t>Random Forest (Nathan)</a:t>
-                      </a:r>
-                    </a:p>
-                  </a:txBody>
-                  <a:tcPr/>
-                </a:tc>
-                <a:tc>
-                  <a:txBody>
-                    <a:bodyPr/>
-                    <a:lstStyle/>
-                    <a:p>
-                      <a:r>
-                        <a:rPr sz="1100"/>
-                        <a:t>TBD</a:t>
-                      </a:r>
-                    </a:p>
-                  </a:txBody>
-                  <a:tcPr/>
-                </a:tc>
-                <a:tc>
-                  <a:txBody>
-                    <a:bodyPr/>
-                    <a:lstStyle/>
-                    <a:p>
-                      <a:r>
-                        <a:rPr sz="1100"/>
-                        <a:t>TBD</a:t>
-                      </a:r>
-                    </a:p>
-                  </a:txBody>
-                  <a:tcPr/>
-                </a:tc>
-              </a:tr>
-              <a:tr h="533400">
-                <a:tc>
-                  <a:txBody>
-                    <a:bodyPr/>
-                    <a:lstStyle/>
-                    <a:p>
-                      <a:r>
-                        <a:rPr sz="1100"/>
-                        <a:t>HistGradBoost (Nathan)</a:t>
-                      </a:r>
-                    </a:p>
-                  </a:txBody>
-                  <a:tcPr/>
-                </a:tc>
-                <a:tc>
-                  <a:txBody>
-                    <a:bodyPr/>
-                    <a:lstStyle/>
-                    <a:p>
-                      <a:r>
-                        <a:rPr sz="1100"/>
-                        <a:t>TBD</a:t>
-                      </a:r>
-                    </a:p>
-                  </a:txBody>
-                  <a:tcPr/>
-                </a:tc>
-                <a:tc>
-                  <a:txBody>
-                    <a:bodyPr/>
-                    <a:lstStyle/>
-                    <a:p>
-                      <a:r>
-                        <a:rPr sz="1100"/>
-                        <a:t>TBD</a:t>
-                      </a:r>
-                    </a:p>
-                  </a:txBody>
-                  <a:tcPr/>
-                </a:tc>
-              </a:tr>
-              <a:tr h="533400">
-                <a:tc>
-                  <a:txBody>
-                    <a:bodyPr/>
-                    <a:lstStyle/>
-                    <a:p>
-                      <a:r>
-                        <a:rPr sz="1100"/>
-                        <a:t>Deep MLP (Minwoo)</a:t>
-                      </a:r>
-                    </a:p>
-                  </a:txBody>
-                  <a:tcPr/>
-                </a:tc>
-                <a:tc>
-                  <a:txBody>
-                    <a:bodyPr/>
-                    <a:lstStyle/>
-                    <a:p>
-                      <a:r>
-                        <a:rPr sz="1100"/>
-                        <a:t>TBD</a:t>
-                      </a:r>
-                    </a:p>
-                  </a:txBody>
-                  <a:tcPr/>
-                </a:tc>
-                <a:tc>
-                  <a:txBody>
-                    <a:bodyPr/>
-                    <a:lstStyle/>
-                    <a:p>
-                      <a:r>
-                        <a:rPr sz="1100"/>
-                        <a:t>TBD</a:t>
                       </a:r>
                     </a:p>
                   </a:txBody>
@@ -4832,14 +4793,14 @@
       </p:graphicFrame>
       <p:sp>
         <p:nvSpPr>
-          <p:cNvPr id="4" name="TextBox 3"/>
+          <p:cNvPr id="5" name="TextBox 4"/>
           <p:cNvSpPr txBox="1"/>
           <p:nvPr/>
         </p:nvSpPr>
         <p:spPr>
           <a:xfrm>
-            <a:off x="548640" y="4754880"/>
-            <a:ext cx="11091672" cy="1645920"/>
+            <a:off x="457200" y="5120640"/>
+            <a:ext cx="11247120" cy="1463040"/>
           </a:xfrm>
           <a:prstGeom prst="rect">
             <a:avLst/>
@@ -4859,28 +4820,21 @@
                   <a:srgbClr val="1F3A68"/>
                 </a:solidFill>
               </a:rPr>
-              <a:t>Highlights</a:t>
+              <a:t>Best model: HistGradBoost (Nathan)  (val ROC AUC = 0.7595)</a:t>
             </a:r>
           </a:p>
           <a:p>
             <a:pPr/>
             <a:r>
               <a:rPr sz="1400" b="0"/>
-              <a:t>• Best model: Shallow MLP (Minwoo)  (val ROC AUC = 0.7405).</a:t>
+              <a:t>• Tree boosting (HGBC) is competitive on tabular credit data, in line with the literature.</a:t>
             </a:r>
           </a:p>
           <a:p>
             <a:pPr/>
             <a:r>
               <a:rPr sz="1400" b="0"/>
-              <a:t>• Tree-boosting (HGBC) is competitive for tabular credit data, consistent with the literature.</a:t>
-            </a:r>
-          </a:p>
-          <a:p>
-            <a:pPr/>
-            <a:r>
-              <a:rPr sz="1400" b="0"/>
-              <a:t>• Neural networks reach a similar regime once features are scaled and the network has enough regularization.</a:t>
+              <a:t>• Neural networks reach a similar regime once features are scaled and regularized.</a:t>
             </a:r>
           </a:p>
         </p:txBody>
@@ -4937,16 +4891,499 @@
           </a:p>
         </p:txBody>
       </p:sp>
-      <p:sp>
-        <p:nvSpPr>
-          <p:cNvPr id="3" name="TextBox 2"/>
+      <p:graphicFrame>
+        <p:nvGraphicFramePr>
+          <p:cNvPr id="3" name="Table 2"/>
+          <p:cNvGraphicFramePr>
+            <a:graphicFrameLocks noGrp="1"/>
+          </p:cNvGraphicFramePr>
+          <p:nvPr/>
+        </p:nvGraphicFramePr>
+        <p:xfrm>
+          <a:off x="548640" y="1097280"/>
+          <a:ext cx="10332720" cy="1645920"/>
+        </p:xfrm>
+        <a:graphic>
+          <a:graphicData uri="http://schemas.openxmlformats.org/drawingml/2006/table">
+            <a:tbl>
+              <a:tblPr firstRow="1" bandRow="1">
+                <a:tableStyleId>{5C22544A-7EE6-4342-B048-85BDC9FD1C3A}</a:tableStyleId>
+              </a:tblPr>
+              <a:tblGrid>
+                <a:gridCol w="1463040"/>
+                <a:gridCol w="1188720"/>
+                <a:gridCol w="1371600"/>
+                <a:gridCol w="1371600"/>
+                <a:gridCol w="1463040"/>
+                <a:gridCol w="1371600"/>
+                <a:gridCol w="2103120"/>
+              </a:tblGrid>
+              <a:tr h="411480">
+                <a:tc>
+                  <a:txBody>
+                    <a:bodyPr/>
+                    <a:lstStyle/>
+                    <a:p>
+                      <a:r>
+                        <a:rPr b="1" sz="1300">
+                          <a:solidFill>
+                            <a:srgbClr val="FFFFFF"/>
+                          </a:solidFill>
+                        </a:rPr>
+                        <a:t>method</a:t>
+                      </a:r>
+                    </a:p>
+                  </a:txBody>
+                  <a:tcPr>
+                    <a:solidFill>
+                      <a:srgbClr val="2E86C1"/>
+                    </a:solidFill>
+                  </a:tcPr>
+                </a:tc>
+                <a:tc>
+                  <a:txBody>
+                    <a:bodyPr/>
+                    <a:lstStyle/>
+                    <a:p>
+                      <a:r>
+                        <a:rPr b="1" sz="1300">
+                          <a:solidFill>
+                            <a:srgbClr val="FFFFFF"/>
+                          </a:solidFill>
+                        </a:rPr>
+                        <a:t>threshold</a:t>
+                      </a:r>
+                    </a:p>
+                  </a:txBody>
+                  <a:tcPr>
+                    <a:solidFill>
+                      <a:srgbClr val="2E86C1"/>
+                    </a:solidFill>
+                  </a:tcPr>
+                </a:tc>
+                <a:tc>
+                  <a:txBody>
+                    <a:bodyPr/>
+                    <a:lstStyle/>
+                    <a:p>
+                      <a:r>
+                        <a:rPr b="1" sz="1300">
+                          <a:solidFill>
+                            <a:srgbClr val="FFFFFF"/>
+                          </a:solidFill>
+                        </a:rPr>
+                        <a:t>ROC_AUC</a:t>
+                      </a:r>
+                    </a:p>
+                  </a:txBody>
+                  <a:tcPr>
+                    <a:solidFill>
+                      <a:srgbClr val="2E86C1"/>
+                    </a:solidFill>
+                  </a:tcPr>
+                </a:tc>
+                <a:tc>
+                  <a:txBody>
+                    <a:bodyPr/>
+                    <a:lstStyle/>
+                    <a:p>
+                      <a:r>
+                        <a:rPr b="1" sz="1300">
+                          <a:solidFill>
+                            <a:srgbClr val="FFFFFF"/>
+                          </a:solidFill>
+                        </a:rPr>
+                        <a:t>PR_AUC</a:t>
+                      </a:r>
+                    </a:p>
+                  </a:txBody>
+                  <a:tcPr>
+                    <a:solidFill>
+                      <a:srgbClr val="2E86C1"/>
+                    </a:solidFill>
+                  </a:tcPr>
+                </a:tc>
+                <a:tc>
+                  <a:txBody>
+                    <a:bodyPr/>
+                    <a:lstStyle/>
+                    <a:p>
+                      <a:r>
+                        <a:rPr b="1" sz="1300">
+                          <a:solidFill>
+                            <a:srgbClr val="FFFFFF"/>
+                          </a:solidFill>
+                        </a:rPr>
+                        <a:t>precision</a:t>
+                      </a:r>
+                    </a:p>
+                  </a:txBody>
+                  <a:tcPr>
+                    <a:solidFill>
+                      <a:srgbClr val="2E86C1"/>
+                    </a:solidFill>
+                  </a:tcPr>
+                </a:tc>
+                <a:tc>
+                  <a:txBody>
+                    <a:bodyPr/>
+                    <a:lstStyle/>
+                    <a:p>
+                      <a:r>
+                        <a:rPr b="1" sz="1300">
+                          <a:solidFill>
+                            <a:srgbClr val="FFFFFF"/>
+                          </a:solidFill>
+                        </a:rPr>
+                        <a:t>recall</a:t>
+                      </a:r>
+                    </a:p>
+                  </a:txBody>
+                  <a:tcPr>
+                    <a:solidFill>
+                      <a:srgbClr val="2E86C1"/>
+                    </a:solidFill>
+                  </a:tcPr>
+                </a:tc>
+                <a:tc>
+                  <a:txBody>
+                    <a:bodyPr/>
+                    <a:lstStyle/>
+                    <a:p>
+                      <a:r>
+                        <a:rPr b="1" sz="1300">
+                          <a:solidFill>
+                            <a:srgbClr val="FFFFFF"/>
+                          </a:solidFill>
+                        </a:rPr>
+                        <a:t>F1</a:t>
+                      </a:r>
+                    </a:p>
+                  </a:txBody>
+                  <a:tcPr>
+                    <a:solidFill>
+                      <a:srgbClr val="2E86C1"/>
+                    </a:solidFill>
+                  </a:tcPr>
+                </a:tc>
+              </a:tr>
+              <a:tr h="411480">
+                <a:tc>
+                  <a:txBody>
+                    <a:bodyPr/>
+                    <a:lstStyle/>
+                    <a:p>
+                      <a:r>
+                        <a:rPr sz="1100"/>
+                        <a:t>baseline</a:t>
+                      </a:r>
+                    </a:p>
+                  </a:txBody>
+                  <a:tcPr/>
+                </a:tc>
+                <a:tc>
+                  <a:txBody>
+                    <a:bodyPr/>
+                    <a:lstStyle/>
+                    <a:p>
+                      <a:r>
+                        <a:rPr sz="1100"/>
+                        <a:t>0.5</a:t>
+                      </a:r>
+                    </a:p>
+                  </a:txBody>
+                  <a:tcPr/>
+                </a:tc>
+                <a:tc>
+                  <a:txBody>
+                    <a:bodyPr/>
+                    <a:lstStyle/>
+                    <a:p>
+                      <a:r>
+                        <a:rPr sz="1100"/>
+                        <a:t>0.745</a:t>
+                      </a:r>
+                    </a:p>
+                  </a:txBody>
+                  <a:tcPr/>
+                </a:tc>
+                <a:tc>
+                  <a:txBody>
+                    <a:bodyPr/>
+                    <a:lstStyle/>
+                    <a:p>
+                      <a:r>
+                        <a:rPr sz="1100"/>
+                        <a:t>0.2215</a:t>
+                      </a:r>
+                    </a:p>
+                  </a:txBody>
+                  <a:tcPr/>
+                </a:tc>
+                <a:tc>
+                  <a:txBody>
+                    <a:bodyPr/>
+                    <a:lstStyle/>
+                    <a:p>
+                      <a:r>
+                        <a:rPr sz="1100"/>
+                        <a:t>0.0</a:t>
+                      </a:r>
+                    </a:p>
+                  </a:txBody>
+                  <a:tcPr/>
+                </a:tc>
+                <a:tc>
+                  <a:txBody>
+                    <a:bodyPr/>
+                    <a:lstStyle/>
+                    <a:p>
+                      <a:r>
+                        <a:rPr sz="1100"/>
+                        <a:t>0.0</a:t>
+                      </a:r>
+                    </a:p>
+                  </a:txBody>
+                  <a:tcPr/>
+                </a:tc>
+                <a:tc>
+                  <a:txBody>
+                    <a:bodyPr/>
+                    <a:lstStyle/>
+                    <a:p>
+                      <a:r>
+                        <a:rPr sz="1100"/>
+                        <a:t>0.0</a:t>
+                      </a:r>
+                    </a:p>
+                  </a:txBody>
+                  <a:tcPr/>
+                </a:tc>
+              </a:tr>
+              <a:tr h="411480">
+                <a:tc>
+                  <a:txBody>
+                    <a:bodyPr/>
+                    <a:lstStyle/>
+                    <a:p>
+                      <a:r>
+                        <a:rPr sz="1100"/>
+                        <a:t>SMOTE</a:t>
+                      </a:r>
+                    </a:p>
+                  </a:txBody>
+                  <a:tcPr/>
+                </a:tc>
+                <a:tc>
+                  <a:txBody>
+                    <a:bodyPr/>
+                    <a:lstStyle/>
+                    <a:p>
+                      <a:r>
+                        <a:rPr sz="1100"/>
+                        <a:t>0.5</a:t>
+                      </a:r>
+                    </a:p>
+                  </a:txBody>
+                  <a:tcPr/>
+                </a:tc>
+                <a:tc>
+                  <a:txBody>
+                    <a:bodyPr/>
+                    <a:lstStyle/>
+                    <a:p>
+                      <a:r>
+                        <a:rPr sz="1100"/>
+                        <a:t>0.6476</a:t>
+                      </a:r>
+                    </a:p>
+                  </a:txBody>
+                  <a:tcPr/>
+                </a:tc>
+                <a:tc>
+                  <a:txBody>
+                    <a:bodyPr/>
+                    <a:lstStyle/>
+                    <a:p>
+                      <a:r>
+                        <a:rPr sz="1100"/>
+                        <a:t>0.1337</a:t>
+                      </a:r>
+                    </a:p>
+                  </a:txBody>
+                  <a:tcPr/>
+                </a:tc>
+                <a:tc>
+                  <a:txBody>
+                    <a:bodyPr/>
+                    <a:lstStyle/>
+                    <a:p>
+                      <a:r>
+                        <a:rPr sz="1100"/>
+                        <a:t>0.1625</a:t>
+                      </a:r>
+                    </a:p>
+                  </a:txBody>
+                  <a:tcPr/>
+                </a:tc>
+                <a:tc>
+                  <a:txBody>
+                    <a:bodyPr/>
+                    <a:lstStyle/>
+                    <a:p>
+                      <a:r>
+                        <a:rPr sz="1100"/>
+                        <a:t>0.205</a:t>
+                      </a:r>
+                    </a:p>
+                  </a:txBody>
+                  <a:tcPr/>
+                </a:tc>
+                <a:tc>
+                  <a:txBody>
+                    <a:bodyPr/>
+                    <a:lstStyle/>
+                    <a:p>
+                      <a:r>
+                        <a:rPr sz="1100"/>
+                        <a:t>0.1813</a:t>
+                      </a:r>
+                    </a:p>
+                  </a:txBody>
+                  <a:tcPr/>
+                </a:tc>
+              </a:tr>
+              <a:tr h="411480">
+                <a:tc>
+                  <a:txBody>
+                    <a:bodyPr/>
+                    <a:lstStyle/>
+                    <a:p>
+                      <a:r>
+                        <a:rPr sz="1100"/>
+                        <a:t>threshold</a:t>
+                      </a:r>
+                    </a:p>
+                  </a:txBody>
+                  <a:tcPr/>
+                </a:tc>
+                <a:tc>
+                  <a:txBody>
+                    <a:bodyPr/>
+                    <a:lstStyle/>
+                    <a:p>
+                      <a:r>
+                        <a:rPr sz="1100"/>
+                        <a:t>0.1641</a:t>
+                      </a:r>
+                    </a:p>
+                  </a:txBody>
+                  <a:tcPr/>
+                </a:tc>
+                <a:tc>
+                  <a:txBody>
+                    <a:bodyPr/>
+                    <a:lstStyle/>
+                    <a:p>
+                      <a:r>
+                        <a:rPr sz="1100"/>
+                        <a:t>0.745</a:t>
+                      </a:r>
+                    </a:p>
+                  </a:txBody>
+                  <a:tcPr/>
+                </a:tc>
+                <a:tc>
+                  <a:txBody>
+                    <a:bodyPr/>
+                    <a:lstStyle/>
+                    <a:p>
+                      <a:r>
+                        <a:rPr sz="1100"/>
+                        <a:t>0.2215</a:t>
+                      </a:r>
+                    </a:p>
+                  </a:txBody>
+                  <a:tcPr/>
+                </a:tc>
+                <a:tc>
+                  <a:txBody>
+                    <a:bodyPr/>
+                    <a:lstStyle/>
+                    <a:p>
+                      <a:r>
+                        <a:rPr sz="1100"/>
+                        <a:t>0.238</a:t>
+                      </a:r>
+                    </a:p>
+                  </a:txBody>
+                  <a:tcPr/>
+                </a:tc>
+                <a:tc>
+                  <a:txBody>
+                    <a:bodyPr/>
+                    <a:lstStyle/>
+                    <a:p>
+                      <a:r>
+                        <a:rPr sz="1100"/>
+                        <a:t>0.4004</a:t>
+                      </a:r>
+                    </a:p>
+                  </a:txBody>
+                  <a:tcPr/>
+                </a:tc>
+                <a:tc>
+                  <a:txBody>
+                    <a:bodyPr/>
+                    <a:lstStyle/>
+                    <a:p>
+                      <a:r>
+                        <a:rPr sz="1100"/>
+                        <a:t>0.2986</a:t>
+                      </a:r>
+                    </a:p>
+                  </a:txBody>
+                  <a:tcPr/>
+                </a:tc>
+              </a:tr>
+            </a:tbl>
+          </a:graphicData>
+        </a:graphic>
+      </p:graphicFrame>
+      <p:pic>
+        <p:nvPicPr>
+          <p:cNvPr id="4" name="Picture 3" descr="imbalance_compare.png"/>
+          <p:cNvPicPr>
+            <a:picLocks noChangeAspect="1"/>
+          </p:cNvPicPr>
+          <p:nvPr/>
+        </p:nvPicPr>
+        <p:blipFill>
+          <a:blip r:embed="rId2"/>
+          <a:stretch>
+            <a:fillRect/>
+          </a:stretch>
+        </p:blipFill>
+        <p:spPr>
+          <a:xfrm>
+            <a:off x="365760" y="2926080"/>
+            <a:ext cx="6766560" cy="3305185"/>
+          </a:xfrm>
+          <a:prstGeom prst="rect">
+            <a:avLst/>
+          </a:prstGeom>
+        </p:spPr>
+      </p:pic>
+      <p:sp>
+        <p:nvSpPr>
+          <p:cNvPr id="5" name="TextBox 4"/>
           <p:cNvSpPr txBox="1"/>
           <p:nvPr/>
         </p:nvSpPr>
         <p:spPr>
           <a:xfrm>
-            <a:off x="548640" y="1188720"/>
-            <a:ext cx="11091672" cy="914400"/>
+            <a:off x="7406640" y="2926080"/>
+            <a:ext cx="4480560" cy="3474720"/>
           </a:xfrm>
           <a:prstGeom prst="rect">
             <a:avLst/>
@@ -4954,40 +5391,6 @@
           <a:noFill/>
         </p:spPr>
         <p:txBody>
-          <a:bodyPr wrap="none">
-            <a:spAutoFit/>
-          </a:bodyPr>
-          <a:lstStyle/>
-          <a:p>
-            <a:pPr algn="l"/>
-            <a:r>
-              <a:rPr sz="1800" b="0">
-                <a:solidFill>
-                  <a:srgbClr val="555555"/>
-                </a:solidFill>
-              </a:rPr>
-              <a:t>&lt;&lt;TBD — fill after notebook completes&gt;&gt;</a:t>
-            </a:r>
-          </a:p>
-        </p:txBody>
-      </p:sp>
-      <p:sp>
-        <p:nvSpPr>
-          <p:cNvPr id="4" name="TextBox 3"/>
-          <p:cNvSpPr txBox="1"/>
-          <p:nvPr/>
-        </p:nvSpPr>
-        <p:spPr>
-          <a:xfrm>
-            <a:off x="548640" y="3657600"/>
-            <a:ext cx="11091672" cy="2743200"/>
-          </a:xfrm>
-          <a:prstGeom prst="rect">
-            <a:avLst/>
-          </a:prstGeom>
-          <a:noFill/>
-        </p:spPr>
-        <p:txBody>
           <a:bodyPr wrap="square">
             <a:spAutoFit/>
           </a:bodyPr>
@@ -4995,33 +5398,33 @@
           <a:p>
             <a:pPr algn="l"/>
             <a:r>
-              <a:rPr sz="1800" b="1">
+              <a:rPr sz="1600" b="1">
                 <a:solidFill>
                   <a:srgbClr val="1F3A68"/>
                 </a:solidFill>
               </a:rPr>
-              <a:t>Three handling strategies (sklearn MLPClassifier does not support class_weight)</a:t>
+              <a:t>Three handling strategies</a:t>
             </a:r>
           </a:p>
           <a:p>
             <a:pPr/>
             <a:r>
-              <a:rPr sz="1400" b="0"/>
-              <a:t>• Baseline — train on the original imbalanced data; classify at 0.5.</a:t>
+              <a:rPr sz="1200" b="0"/>
+              <a:t>• Baseline — original 8/92 split, classify at 0.5.</a:t>
             </a:r>
           </a:p>
           <a:p>
             <a:pPr/>
             <a:r>
-              <a:rPr sz="1400" b="0"/>
-              <a:t>• SMOTE — synthesize minority samples until 50/50 in training only; classify at 0.5.</a:t>
+              <a:rPr sz="1200" b="0"/>
+              <a:t>• SMOTE — oversample minority to 50/50 (train only).</a:t>
             </a:r>
           </a:p>
           <a:p>
             <a:pPr/>
             <a:r>
-              <a:rPr sz="1400" b="0"/>
-              <a:t>• Threshold tuning — keep the baseline model, choose the threshold that maximizes F1 on validation.</a:t>
+              <a:rPr sz="1200" b="0"/>
+              <a:t>• Threshold tuning — pick the threshold maximizing F1 on val.</a:t>
             </a:r>
           </a:p>
           <a:p>
@@ -5030,26 +5433,33 @@
           <a:p>
             <a:pPr/>
             <a:r>
-              <a:rPr sz="1800" b="1">
+              <a:rPr sz="1600" b="1">
                 <a:solidFill>
                   <a:srgbClr val="1F3A68"/>
                 </a:solidFill>
               </a:rPr>
-              <a:t>Reading the table</a:t>
+              <a:t>Reading the chart</a:t>
             </a:r>
           </a:p>
           <a:p>
             <a:pPr/>
             <a:r>
-              <a:rPr sz="1400" b="0"/>
-              <a:t>• Threshold tuning trades precision for recall (ROC AUC unchanged by definition).</a:t>
+              <a:rPr sz="1200" b="0"/>
+              <a:t>• Threshold tuning swaps precision for recall.</a:t>
             </a:r>
           </a:p>
           <a:p>
             <a:pPr/>
             <a:r>
-              <a:rPr sz="1400" b="0"/>
-              <a:t>• SMOTE typically improves recall but can hurt precision.</a:t>
+              <a:rPr sz="1200" b="0"/>
+              <a:t>• SMOTE typically lifts recall but can hurt precision.</a:t>
+            </a:r>
+          </a:p>
+          <a:p>
+            <a:pPr/>
+            <a:r>
+              <a:rPr sz="1200" b="0"/>
+              <a:t>• ROC AUC barely moves — the model already produces a good ranking.</a:t>
             </a:r>
           </a:p>
         </p:txBody>
@@ -5141,29 +5551,36 @@
           <a:p>
             <a:pPr/>
             <a:r>
-              <a:rPr sz="1600" b="0"/>
-              <a:t>• Best model overall: Shallow MLP (Minwoo) (val ROC AUC = 0.7405).</a:t>
+              <a:rPr sz="1500" b="0"/>
+              <a:t>• Best model: HistGradBoost (Nathan) at val ROC AUC = 0.7595; tree boosting wins by about 1 AUC point.</a:t>
             </a:r>
           </a:p>
           <a:p>
             <a:pPr/>
             <a:r>
-              <a:rPr sz="1600" b="0"/>
-              <a:t>• Gradient boosting (HGBC) tends to outperform both linear and neural networks on this tabular task.</a:t>
+              <a:rPr sz="1500" b="0"/>
+              <a:t>• Neural networks tie Logistic Regression and Random Forest — bottleneck is the feature set, not the model.</a:t>
             </a:r>
           </a:p>
           <a:p>
             <a:pPr/>
             <a:r>
-              <a:rPr sz="1600" b="0"/>
-              <a:t>• Neural networks need feature scaling AND regularization (alpha) to compete; deeper is not automatically better.</a:t>
+              <a:rPr sz="1500" b="0"/>
+              <a:t>• Shallow MLP (0.7405) ≈ Deep MLP (0.7416): going deeper does not help on this tabular data.</a:t>
             </a:r>
           </a:p>
           <a:p>
             <a:pPr/>
             <a:r>
-              <a:rPr sz="1600" b="0"/>
-              <a:t>• Imbalance handling on the MLP shifts precision↔recall but does not move ROC AUC much — the model already learns a useful ranking.</a:t>
+              <a:rPr sz="1500" b="1"/>
+              <a:t>• Most actionable finding: at 0.5 threshold the MLP has zero recall — *choosing the threshold matters more than resampling.*</a:t>
+            </a:r>
+          </a:p>
+          <a:p>
+            <a:pPr/>
+            <a:r>
+              <a:rPr sz="1500" b="0"/>
+              <a:t>• SMOTE actually hurt this MLP (AUC 0.745 → 0.648); threshold tuning preserved AUC and lifted recall to 40 %.</a:t>
             </a:r>
           </a:p>
           <a:p>
@@ -5177,42 +5594,28 @@
                   <a:srgbClr val="1F3A68"/>
                 </a:solidFill>
               </a:rPr>
-              <a:t>Limitations</a:t>
+              <a:t>Limitations &amp; future work</a:t>
             </a:r>
           </a:p>
           <a:p>
             <a:pPr/>
             <a:r>
-              <a:rPr sz="1600" b="0"/>
-              <a:t>• Only the main application_*.csv tables are used; the bureau / previous_application tables would likely add several AUC points.</a:t>
+              <a:rPr sz="1400" b="0"/>
+              <a:t>• Only the main application_*.csv tables used — auxiliary tables (bureau, previous_application) typically add several AUC points.</a:t>
             </a:r>
           </a:p>
           <a:p>
             <a:pPr/>
             <a:r>
-              <a:rPr sz="1600" b="0"/>
-              <a:t>• PredefinedSplit is fast but optimistic; full k-fold CV would give tighter confidence intervals.</a:t>
+              <a:rPr sz="1400" b="0"/>
+              <a:t>• PredefinedSplit is fast but optimistic; k-fold CV would tighten the confidence intervals.</a:t>
             </a:r>
           </a:p>
           <a:p>
             <a:pPr/>
-          </a:p>
-          <a:p>
-            <a:pPr/>
-            <a:r>
-              <a:rPr sz="2000" b="1">
-                <a:solidFill>
-                  <a:srgbClr val="1F3A68"/>
-                </a:solidFill>
-              </a:rPr>
-              <a:t>Future work</a:t>
-            </a:r>
-          </a:p>
-          <a:p>
-            <a:pPr/>
-            <a:r>
-              <a:rPr sz="1600" b="0"/>
-              <a:t>• Integrate auxiliary tables; ensemble HGBC and the best MLP; calibrate probabilities (Platt or isotonic).</a:t>
+            <a:r>
+              <a:rPr sz="1400" b="0"/>
+              <a:t>• Next steps: integrate auxiliary tables; ensemble HGBC + best MLP; calibrate probabilities (Platt / isotonic).</a:t>
             </a:r>
           </a:p>
         </p:txBody>

</xml_diff>